<commit_message>
chore: v2.14.2 lanjutan — PPTX editabel berlogo BPF (12 slide), ONEPAGER badge + 106 pytest, push ke origin
</commit_message>
<xml_diff>
--- a/presentasi/BPF_Fleet_BBM_System_Presentasi.pptx
+++ b/presentasi/BPF_Fleet_BBM_System_Presentasi.pptx
@@ -3223,9 +3223,33 @@
           </a:p>
         </p:txBody>
       </p:sp>
-      <p:sp>
-        <p:nvSpPr>
-          <p:cNvPr id="5" name="TextBox 4"/>
+      <p:pic>
+        <p:nvPicPr>
+          <p:cNvPr id="5" name="Picture 4" descr="bpf-badge.png"/>
+          <p:cNvPicPr>
+            <a:picLocks noChangeAspect="1"/>
+          </p:cNvPicPr>
+          <p:nvPr/>
+        </p:nvPicPr>
+        <p:blipFill>
+          <a:blip r:embed="rId2"/>
+          <a:stretch>
+            <a:fillRect/>
+          </a:stretch>
+        </p:blipFill>
+        <p:spPr>
+          <a:xfrm>
+            <a:off x="9966960" y="320040"/>
+            <a:ext cx="1554480" cy="1554480"/>
+          </a:xfrm>
+          <a:prstGeom prst="rect">
+            <a:avLst/>
+          </a:prstGeom>
+        </p:spPr>
+      </p:pic>
+      <p:sp>
+        <p:nvSpPr>
+          <p:cNvPr id="6" name="TextBox 5"/>
           <p:cNvSpPr txBox="1"/>
           <p:nvPr/>
         </p:nvSpPr>
@@ -3263,7 +3287,7 @@
       </p:sp>
       <p:sp>
         <p:nvSpPr>
-          <p:cNvPr id="6" name="TextBox 5"/>
+          <p:cNvPr id="7" name="TextBox 6"/>
           <p:cNvSpPr txBox="1"/>
           <p:nvPr/>
         </p:nvSpPr>
@@ -3301,7 +3325,7 @@
       </p:sp>
       <p:sp>
         <p:nvSpPr>
-          <p:cNvPr id="7" name="Rectangle 6"/>
+          <p:cNvPr id="8" name="Rectangle 7"/>
           <p:cNvSpPr/>
           <p:nvPr/>
         </p:nvSpPr>
@@ -3346,7 +3370,7 @@
       </p:sp>
       <p:sp>
         <p:nvSpPr>
-          <p:cNvPr id="8" name="TextBox 7"/>
+          <p:cNvPr id="9" name="TextBox 8"/>
           <p:cNvSpPr txBox="1"/>
           <p:nvPr/>
         </p:nvSpPr>
@@ -3384,7 +3408,7 @@
       </p:sp>
       <p:sp>
         <p:nvSpPr>
-          <p:cNvPr id="9" name="TextBox 8"/>
+          <p:cNvPr id="10" name="TextBox 9"/>
           <p:cNvSpPr txBox="1"/>
           <p:nvPr/>
         </p:nvSpPr>
@@ -3422,7 +3446,7 @@
       </p:sp>
       <p:sp>
         <p:nvSpPr>
-          <p:cNvPr id="10" name="TextBox 9"/>
+          <p:cNvPr id="11" name="TextBox 10"/>
           <p:cNvSpPr txBox="1"/>
           <p:nvPr/>
         </p:nvSpPr>
@@ -3460,7 +3484,7 @@
       </p:sp>
       <p:sp>
         <p:nvSpPr>
-          <p:cNvPr id="11" name="Rectangle 10"/>
+          <p:cNvPr id="12" name="Rectangle 11"/>
           <p:cNvSpPr/>
           <p:nvPr/>
         </p:nvSpPr>
@@ -3505,7 +3529,7 @@
       </p:sp>
       <p:sp>
         <p:nvSpPr>
-          <p:cNvPr id="12" name="TextBox 11"/>
+          <p:cNvPr id="13" name="TextBox 12"/>
           <p:cNvSpPr txBox="1"/>
           <p:nvPr/>
         </p:nvSpPr>
@@ -3543,7 +3567,7 @@
       </p:sp>
       <p:sp>
         <p:nvSpPr>
-          <p:cNvPr id="13" name="TextBox 12"/>
+          <p:cNvPr id="14" name="TextBox 13"/>
           <p:cNvSpPr txBox="1"/>
           <p:nvPr/>
         </p:nvSpPr>
@@ -3581,7 +3605,7 @@
       </p:sp>
       <p:sp>
         <p:nvSpPr>
-          <p:cNvPr id="14" name="TextBox 13"/>
+          <p:cNvPr id="15" name="TextBox 14"/>
           <p:cNvSpPr txBox="1"/>
           <p:nvPr/>
         </p:nvSpPr>
@@ -3619,7 +3643,7 @@
       </p:sp>
       <p:sp>
         <p:nvSpPr>
-          <p:cNvPr id="15" name="Rectangle 14"/>
+          <p:cNvPr id="16" name="Rectangle 15"/>
           <p:cNvSpPr/>
           <p:nvPr/>
         </p:nvSpPr>
@@ -3664,7 +3688,7 @@
       </p:sp>
       <p:sp>
         <p:nvSpPr>
-          <p:cNvPr id="16" name="TextBox 15"/>
+          <p:cNvPr id="17" name="TextBox 16"/>
           <p:cNvSpPr txBox="1"/>
           <p:nvPr/>
         </p:nvSpPr>
@@ -3702,7 +3726,7 @@
       </p:sp>
       <p:sp>
         <p:nvSpPr>
-          <p:cNvPr id="17" name="TextBox 16"/>
+          <p:cNvPr id="18" name="TextBox 17"/>
           <p:cNvSpPr txBox="1"/>
           <p:nvPr/>
         </p:nvSpPr>
@@ -3740,7 +3764,7 @@
       </p:sp>
       <p:sp>
         <p:nvSpPr>
-          <p:cNvPr id="18" name="TextBox 17"/>
+          <p:cNvPr id="19" name="TextBox 18"/>
           <p:cNvSpPr txBox="1"/>
           <p:nvPr/>
         </p:nvSpPr>
@@ -3778,7 +3802,7 @@
       </p:sp>
       <p:sp>
         <p:nvSpPr>
-          <p:cNvPr id="19" name="Rectangle 18"/>
+          <p:cNvPr id="20" name="Rectangle 19"/>
           <p:cNvSpPr/>
           <p:nvPr/>
         </p:nvSpPr>
@@ -3823,7 +3847,7 @@
       </p:sp>
       <p:sp>
         <p:nvSpPr>
-          <p:cNvPr id="20" name="TextBox 19"/>
+          <p:cNvPr id="21" name="TextBox 20"/>
           <p:cNvSpPr txBox="1"/>
           <p:nvPr/>
         </p:nvSpPr>
@@ -3861,7 +3885,7 @@
       </p:sp>
       <p:sp>
         <p:nvSpPr>
-          <p:cNvPr id="21" name="TextBox 20"/>
+          <p:cNvPr id="22" name="TextBox 21"/>
           <p:cNvSpPr txBox="1"/>
           <p:nvPr/>
         </p:nvSpPr>
@@ -3899,7 +3923,7 @@
       </p:sp>
       <p:sp>
         <p:nvSpPr>
-          <p:cNvPr id="22" name="TextBox 21"/>
+          <p:cNvPr id="23" name="TextBox 22"/>
           <p:cNvSpPr txBox="1"/>
           <p:nvPr/>
         </p:nvSpPr>
@@ -3935,9 +3959,33 @@
           </a:p>
         </p:txBody>
       </p:sp>
-      <p:sp>
-        <p:nvSpPr>
-          <p:cNvPr id="23" name="TextBox 22"/>
+      <p:pic>
+        <p:nvPicPr>
+          <p:cNvPr id="24" name="Picture 23" descr="bpf-badge.png"/>
+          <p:cNvPicPr>
+            <a:picLocks noChangeAspect="1"/>
+          </p:cNvPicPr>
+          <p:nvPr/>
+        </p:nvPicPr>
+        <p:blipFill>
+          <a:blip r:embed="rId2"/>
+          <a:stretch>
+            <a:fillRect/>
+          </a:stretch>
+        </p:blipFill>
+        <p:spPr>
+          <a:xfrm>
+            <a:off x="274320" y="6355080"/>
+            <a:ext cx="457200" cy="457200"/>
+          </a:xfrm>
+          <a:prstGeom prst="rect">
+            <a:avLst/>
+          </a:prstGeom>
+        </p:spPr>
+      </p:pic>
+      <p:sp>
+        <p:nvSpPr>
+          <p:cNvPr id="25" name="TextBox 24"/>
           <p:cNvSpPr txBox="1"/>
           <p:nvPr/>
         </p:nvSpPr>
@@ -4498,9 +4546,33 @@
           </a:p>
         </p:txBody>
       </p:sp>
-      <p:sp>
-        <p:nvSpPr>
-          <p:cNvPr id="7" name="TextBox 6"/>
+      <p:pic>
+        <p:nvPicPr>
+          <p:cNvPr id="7" name="Picture 6" descr="bpf-badge.png"/>
+          <p:cNvPicPr>
+            <a:picLocks noChangeAspect="1"/>
+          </p:cNvPicPr>
+          <p:nvPr/>
+        </p:nvPicPr>
+        <p:blipFill>
+          <a:blip r:embed="rId2"/>
+          <a:stretch>
+            <a:fillRect/>
+          </a:stretch>
+        </p:blipFill>
+        <p:spPr>
+          <a:xfrm>
+            <a:off x="274320" y="6355080"/>
+            <a:ext cx="457200" cy="457200"/>
+          </a:xfrm>
+          <a:prstGeom prst="rect">
+            <a:avLst/>
+          </a:prstGeom>
+        </p:spPr>
+      </p:pic>
+      <p:sp>
+        <p:nvSpPr>
+          <p:cNvPr id="8" name="TextBox 7"/>
           <p:cNvSpPr txBox="1"/>
           <p:nvPr/>
         </p:nvSpPr>
@@ -5347,9 +5419,33 @@
           </a:p>
         </p:txBody>
       </p:sp>
-      <p:sp>
-        <p:nvSpPr>
-          <p:cNvPr id="22" name="TextBox 21"/>
+      <p:pic>
+        <p:nvPicPr>
+          <p:cNvPr id="22" name="Picture 21" descr="bpf-badge.png"/>
+          <p:cNvPicPr>
+            <a:picLocks noChangeAspect="1"/>
+          </p:cNvPicPr>
+          <p:nvPr/>
+        </p:nvPicPr>
+        <p:blipFill>
+          <a:blip r:embed="rId2"/>
+          <a:stretch>
+            <a:fillRect/>
+          </a:stretch>
+        </p:blipFill>
+        <p:spPr>
+          <a:xfrm>
+            <a:off x="274320" y="6355080"/>
+            <a:ext cx="457200" cy="457200"/>
+          </a:xfrm>
+          <a:prstGeom prst="rect">
+            <a:avLst/>
+          </a:prstGeom>
+        </p:spPr>
+      </p:pic>
+      <p:sp>
+        <p:nvSpPr>
+          <p:cNvPr id="23" name="TextBox 22"/>
           <p:cNvSpPr txBox="1"/>
           <p:nvPr/>
         </p:nvSpPr>
@@ -5760,9 +5856,33 @@
           </a:p>
         </p:txBody>
       </p:sp>
-      <p:sp>
-        <p:nvSpPr>
-          <p:cNvPr id="11" name="TextBox 10"/>
+      <p:pic>
+        <p:nvPicPr>
+          <p:cNvPr id="11" name="Picture 10" descr="bpf-badge.png"/>
+          <p:cNvPicPr>
+            <a:picLocks noChangeAspect="1"/>
+          </p:cNvPicPr>
+          <p:nvPr/>
+        </p:nvPicPr>
+        <p:blipFill>
+          <a:blip r:embed="rId2"/>
+          <a:stretch>
+            <a:fillRect/>
+          </a:stretch>
+        </p:blipFill>
+        <p:spPr>
+          <a:xfrm>
+            <a:off x="274320" y="6355080"/>
+            <a:ext cx="457200" cy="457200"/>
+          </a:xfrm>
+          <a:prstGeom prst="rect">
+            <a:avLst/>
+          </a:prstGeom>
+        </p:spPr>
+      </p:pic>
+      <p:sp>
+        <p:nvSpPr>
+          <p:cNvPr id="12" name="TextBox 11"/>
           <p:cNvSpPr txBox="1"/>
           <p:nvPr/>
         </p:nvSpPr>
@@ -6056,9 +6176,33 @@
           </a:p>
         </p:txBody>
       </p:sp>
-      <p:sp>
-        <p:nvSpPr>
-          <p:cNvPr id="7" name="TextBox 6"/>
+      <p:pic>
+        <p:nvPicPr>
+          <p:cNvPr id="7" name="Picture 6" descr="bpf-badge.png"/>
+          <p:cNvPicPr>
+            <a:picLocks noChangeAspect="1"/>
+          </p:cNvPicPr>
+          <p:nvPr/>
+        </p:nvPicPr>
+        <p:blipFill>
+          <a:blip r:embed="rId2"/>
+          <a:stretch>
+            <a:fillRect/>
+          </a:stretch>
+        </p:blipFill>
+        <p:spPr>
+          <a:xfrm>
+            <a:off x="274320" y="6355080"/>
+            <a:ext cx="457200" cy="457200"/>
+          </a:xfrm>
+          <a:prstGeom prst="rect">
+            <a:avLst/>
+          </a:prstGeom>
+        </p:spPr>
+      </p:pic>
+      <p:sp>
+        <p:nvSpPr>
+          <p:cNvPr id="8" name="TextBox 7"/>
           <p:cNvSpPr txBox="1"/>
           <p:nvPr/>
         </p:nvSpPr>
@@ -6711,9 +6855,33 @@
           </a:p>
         </p:txBody>
       </p:sp>
-      <p:sp>
-        <p:nvSpPr>
-          <p:cNvPr id="8" name="TextBox 7"/>
+      <p:pic>
+        <p:nvPicPr>
+          <p:cNvPr id="8" name="Picture 7" descr="bpf-badge.png"/>
+          <p:cNvPicPr>
+            <a:picLocks noChangeAspect="1"/>
+          </p:cNvPicPr>
+          <p:nvPr/>
+        </p:nvPicPr>
+        <p:blipFill>
+          <a:blip r:embed="rId2"/>
+          <a:stretch>
+            <a:fillRect/>
+          </a:stretch>
+        </p:blipFill>
+        <p:spPr>
+          <a:xfrm>
+            <a:off x="274320" y="6355080"/>
+            <a:ext cx="457200" cy="457200"/>
+          </a:xfrm>
+          <a:prstGeom prst="rect">
+            <a:avLst/>
+          </a:prstGeom>
+        </p:spPr>
+      </p:pic>
+      <p:sp>
+        <p:nvSpPr>
+          <p:cNvPr id="9" name="TextBox 8"/>
           <p:cNvSpPr txBox="1"/>
           <p:nvPr/>
         </p:nvSpPr>
@@ -7454,9 +7622,33 @@
           </a:p>
         </p:txBody>
       </p:sp>
-      <p:sp>
-        <p:nvSpPr>
-          <p:cNvPr id="19" name="TextBox 18"/>
+      <p:pic>
+        <p:nvPicPr>
+          <p:cNvPr id="19" name="Picture 18" descr="bpf-badge.png"/>
+          <p:cNvPicPr>
+            <a:picLocks noChangeAspect="1"/>
+          </p:cNvPicPr>
+          <p:nvPr/>
+        </p:nvPicPr>
+        <p:blipFill>
+          <a:blip r:embed="rId2"/>
+          <a:stretch>
+            <a:fillRect/>
+          </a:stretch>
+        </p:blipFill>
+        <p:spPr>
+          <a:xfrm>
+            <a:off x="274320" y="6355080"/>
+            <a:ext cx="457200" cy="457200"/>
+          </a:xfrm>
+          <a:prstGeom prst="rect">
+            <a:avLst/>
+          </a:prstGeom>
+        </p:spPr>
+      </p:pic>
+      <p:sp>
+        <p:nvSpPr>
+          <p:cNvPr id="20" name="TextBox 19"/>
           <p:cNvSpPr txBox="1"/>
           <p:nvPr/>
         </p:nvSpPr>
@@ -7962,9 +8154,33 @@
           </a:p>
         </p:txBody>
       </p:sp>
-      <p:sp>
-        <p:nvSpPr>
-          <p:cNvPr id="8" name="TextBox 7"/>
+      <p:pic>
+        <p:nvPicPr>
+          <p:cNvPr id="8" name="Picture 7" descr="bpf-badge.png"/>
+          <p:cNvPicPr>
+            <a:picLocks noChangeAspect="1"/>
+          </p:cNvPicPr>
+          <p:nvPr/>
+        </p:nvPicPr>
+        <p:blipFill>
+          <a:blip r:embed="rId2"/>
+          <a:stretch>
+            <a:fillRect/>
+          </a:stretch>
+        </p:blipFill>
+        <p:spPr>
+          <a:xfrm>
+            <a:off x="274320" y="6355080"/>
+            <a:ext cx="457200" cy="457200"/>
+          </a:xfrm>
+          <a:prstGeom prst="rect">
+            <a:avLst/>
+          </a:prstGeom>
+        </p:spPr>
+      </p:pic>
+      <p:sp>
+        <p:nvSpPr>
+          <p:cNvPr id="9" name="TextBox 8"/>
           <p:cNvSpPr txBox="1"/>
           <p:nvPr/>
         </p:nvSpPr>
@@ -8720,9 +8936,33 @@
           </a:p>
         </p:txBody>
       </p:sp>
-      <p:sp>
-        <p:nvSpPr>
-          <p:cNvPr id="8" name="TextBox 7"/>
+      <p:pic>
+        <p:nvPicPr>
+          <p:cNvPr id="8" name="Picture 7" descr="bpf-badge.png"/>
+          <p:cNvPicPr>
+            <a:picLocks noChangeAspect="1"/>
+          </p:cNvPicPr>
+          <p:nvPr/>
+        </p:nvPicPr>
+        <p:blipFill>
+          <a:blip r:embed="rId2"/>
+          <a:stretch>
+            <a:fillRect/>
+          </a:stretch>
+        </p:blipFill>
+        <p:spPr>
+          <a:xfrm>
+            <a:off x="274320" y="6355080"/>
+            <a:ext cx="457200" cy="457200"/>
+          </a:xfrm>
+          <a:prstGeom prst="rect">
+            <a:avLst/>
+          </a:prstGeom>
+        </p:spPr>
+      </p:pic>
+      <p:sp>
+        <p:nvSpPr>
+          <p:cNvPr id="9" name="TextBox 8"/>
           <p:cNvSpPr txBox="1"/>
           <p:nvPr/>
         </p:nvSpPr>
@@ -9410,9 +9650,33 @@
           </a:p>
         </p:txBody>
       </p:sp>
-      <p:sp>
-        <p:nvSpPr>
-          <p:cNvPr id="18" name="TextBox 17"/>
+      <p:pic>
+        <p:nvPicPr>
+          <p:cNvPr id="18" name="Picture 17" descr="bpf-badge.png"/>
+          <p:cNvPicPr>
+            <a:picLocks noChangeAspect="1"/>
+          </p:cNvPicPr>
+          <p:nvPr/>
+        </p:nvPicPr>
+        <p:blipFill>
+          <a:blip r:embed="rId2"/>
+          <a:stretch>
+            <a:fillRect/>
+          </a:stretch>
+        </p:blipFill>
+        <p:spPr>
+          <a:xfrm>
+            <a:off x="274320" y="6355080"/>
+            <a:ext cx="457200" cy="457200"/>
+          </a:xfrm>
+          <a:prstGeom prst="rect">
+            <a:avLst/>
+          </a:prstGeom>
+        </p:spPr>
+      </p:pic>
+      <p:sp>
+        <p:nvSpPr>
+          <p:cNvPr id="19" name="TextBox 18"/>
           <p:cNvSpPr txBox="1"/>
           <p:nvPr/>
         </p:nvSpPr>
@@ -9721,9 +9985,33 @@
           </a:p>
         </p:txBody>
       </p:sp>
-      <p:sp>
-        <p:nvSpPr>
-          <p:cNvPr id="7" name="TextBox 6"/>
+      <p:pic>
+        <p:nvPicPr>
+          <p:cNvPr id="7" name="Picture 6" descr="bpf-badge.png"/>
+          <p:cNvPicPr>
+            <a:picLocks noChangeAspect="1"/>
+          </p:cNvPicPr>
+          <p:nvPr/>
+        </p:nvPicPr>
+        <p:blipFill>
+          <a:blip r:embed="rId2"/>
+          <a:stretch>
+            <a:fillRect/>
+          </a:stretch>
+        </p:blipFill>
+        <p:spPr>
+          <a:xfrm>
+            <a:off x="274320" y="6355080"/>
+            <a:ext cx="457200" cy="457200"/>
+          </a:xfrm>
+          <a:prstGeom prst="rect">
+            <a:avLst/>
+          </a:prstGeom>
+        </p:spPr>
+      </p:pic>
+      <p:sp>
+        <p:nvSpPr>
+          <p:cNvPr id="8" name="TextBox 7"/>
           <p:cNvSpPr txBox="1"/>
           <p:nvPr/>
         </p:nvSpPr>
@@ -10252,9 +10540,33 @@
           </a:p>
         </p:txBody>
       </p:sp>
-      <p:sp>
-        <p:nvSpPr>
-          <p:cNvPr id="14" name="TextBox 13"/>
+      <p:pic>
+        <p:nvPicPr>
+          <p:cNvPr id="14" name="Picture 13" descr="bpf-badge.png"/>
+          <p:cNvPicPr>
+            <a:picLocks noChangeAspect="1"/>
+          </p:cNvPicPr>
+          <p:nvPr/>
+        </p:nvPicPr>
+        <p:blipFill>
+          <a:blip r:embed="rId2"/>
+          <a:stretch>
+            <a:fillRect/>
+          </a:stretch>
+        </p:blipFill>
+        <p:spPr>
+          <a:xfrm>
+            <a:off x="274320" y="6355080"/>
+            <a:ext cx="457200" cy="457200"/>
+          </a:xfrm>
+          <a:prstGeom prst="rect">
+            <a:avLst/>
+          </a:prstGeom>
+        </p:spPr>
+      </p:pic>
+      <p:sp>
+        <p:nvSpPr>
+          <p:cNvPr id="15" name="TextBox 14"/>
           <p:cNvSpPr txBox="1"/>
           <p:nvPr/>
         </p:nvSpPr>

</xml_diff>